<commit_message>
Parks deck: add cover + follow-up/next-steps slide
- Cover slide (now slide 1): 'Parks Family Meats — Supplier Calls'
- Closing slide (slide 5): follow-up questions (labels & work instructions for
  666541s; anything else missing?), leaf-fat inspection note (today), and a
  thank-you. Deck is now 5 slides.

Co-Authored-By: Claude Opus 4.8 <noreply@anthropic.com>
Claude-Session: https://claude.ai/code/session_014UGcEfvuC9NvQ5rauRTTbR
</commit_message>
<xml_diff>
--- a/QC inspections suppliers/Parks_Quality_DeepDive_Jun_Jul_2026.pptx
+++ b/QC inspections suppliers/Parks_Quality_DeepDive_Jun_Jul_2026.pptx
@@ -5,9 +5,11 @@
     <p:sldMasterId id="2147483648" r:id="rId1"/>
   </p:sldMasterIdLst>
   <p:sldIdLst>
+    <p:sldId id="259" r:id="rId10"/>
     <p:sldId id="256" r:id="rId7"/>
     <p:sldId id="257" r:id="rId8"/>
     <p:sldId id="258" r:id="rId9"/>
+    <p:sldId id="260" r:id="rId11"/>
   </p:sldIdLst>
   <p:sldSz cx="12191695" cy="6858000" type="screen4x3"/>
   <p:notesSz cx="6858000" cy="9144000"/>
@@ -6229,6 +6231,1097 @@
 </p:sld>
 </file>
 
+<file path=ppt/slides/slide4.xml><?xml version="1.0" encoding="utf-8"?>
+<p:sld xmlns:a="http://schemas.openxmlformats.org/drawingml/2006/main" xmlns:p="http://schemas.openxmlformats.org/presentationml/2006/main" xmlns:r="http://schemas.openxmlformats.org/officeDocument/2006/relationships">
+  <p:cSld>
+    <p:spTree>
+      <p:nvGrpSpPr>
+        <p:cNvPr id="1" name=""/>
+        <p:cNvGrpSpPr/>
+        <p:nvPr/>
+      </p:nvGrpSpPr>
+      <p:grpSpPr/>
+      <p:sp>
+        <p:nvSpPr>
+          <p:cNvPr id="2" name="Rectangle 1"/>
+          <p:cNvSpPr/>
+          <p:nvPr/>
+        </p:nvSpPr>
+        <p:spPr>
+          <a:xfrm>
+            <a:off x="0" y="0"/>
+            <a:ext cx="12191695" cy="6858000"/>
+          </a:xfrm>
+          <a:prstGeom prst="rect">
+            <a:avLst/>
+          </a:prstGeom>
+          <a:solidFill>
+            <a:srgbClr val="FFFFFF"/>
+          </a:solidFill>
+          <a:ln>
+            <a:noFill/>
+          </a:ln>
+          <a:effectLst/>
+        </p:spPr>
+        <p:style>
+          <a:lnRef idx="1">
+            <a:schemeClr val="accent1"/>
+          </a:lnRef>
+          <a:fillRef idx="3">
+            <a:schemeClr val="accent1"/>
+          </a:fillRef>
+          <a:effectRef idx="2">
+            <a:schemeClr val="accent1"/>
+          </a:effectRef>
+          <a:fontRef idx="minor">
+            <a:schemeClr val="lt1"/>
+          </a:fontRef>
+        </p:style>
+        <p:txBody>
+          <a:bodyPr rtlCol="0" anchor="ctr"/>
+          <a:lstStyle/>
+          <a:p>
+            <a:pPr algn="ctr"/>
+          </a:p>
+        </p:txBody>
+      </p:sp>
+      <p:sp>
+        <p:nvSpPr>
+          <p:cNvPr id="3" name="Rectangle 2"/>
+          <p:cNvSpPr/>
+          <p:nvPr/>
+        </p:nvSpPr>
+        <p:spPr>
+          <a:xfrm>
+            <a:off x="0" y="0"/>
+            <a:ext cx="292608" cy="6858000"/>
+          </a:xfrm>
+          <a:prstGeom prst="rect">
+            <a:avLst/>
+          </a:prstGeom>
+          <a:solidFill>
+            <a:srgbClr val="0E7490"/>
+          </a:solidFill>
+          <a:ln>
+            <a:noFill/>
+          </a:ln>
+          <a:effectLst/>
+        </p:spPr>
+        <p:style>
+          <a:lnRef idx="1">
+            <a:schemeClr val="accent1"/>
+          </a:lnRef>
+          <a:fillRef idx="3">
+            <a:schemeClr val="accent1"/>
+          </a:fillRef>
+          <a:effectRef idx="2">
+            <a:schemeClr val="accent1"/>
+          </a:effectRef>
+          <a:fontRef idx="minor">
+            <a:schemeClr val="lt1"/>
+          </a:fontRef>
+        </p:style>
+        <p:txBody>
+          <a:bodyPr rtlCol="0" anchor="ctr"/>
+          <a:lstStyle/>
+          <a:p>
+            <a:pPr algn="ctr"/>
+          </a:p>
+        </p:txBody>
+      </p:sp>
+      <p:sp>
+        <p:nvSpPr>
+          <p:cNvPr id="4" name="Rectangle 3"/>
+          <p:cNvSpPr/>
+          <p:nvPr/>
+        </p:nvSpPr>
+        <p:spPr>
+          <a:xfrm>
+            <a:off x="0" y="6446520"/>
+            <a:ext cx="12191695" cy="411480"/>
+          </a:xfrm>
+          <a:prstGeom prst="rect">
+            <a:avLst/>
+          </a:prstGeom>
+          <a:solidFill>
+            <a:srgbClr val="1F2937"/>
+          </a:solidFill>
+          <a:ln>
+            <a:noFill/>
+          </a:ln>
+          <a:effectLst/>
+        </p:spPr>
+        <p:style>
+          <a:lnRef idx="1">
+            <a:schemeClr val="accent1"/>
+          </a:lnRef>
+          <a:fillRef idx="3">
+            <a:schemeClr val="accent1"/>
+          </a:fillRef>
+          <a:effectRef idx="2">
+            <a:schemeClr val="accent1"/>
+          </a:effectRef>
+          <a:fontRef idx="minor">
+            <a:schemeClr val="lt1"/>
+          </a:fontRef>
+        </p:style>
+        <p:txBody>
+          <a:bodyPr rtlCol="0" anchor="ctr"/>
+          <a:lstStyle/>
+          <a:p>
+            <a:pPr algn="ctr"/>
+          </a:p>
+        </p:txBody>
+      </p:sp>
+      <p:sp>
+        <p:nvSpPr>
+          <p:cNvPr id="5" name="TextBox 4"/>
+          <p:cNvSpPr txBox="1"/>
+          <p:nvPr/>
+        </p:nvSpPr>
+        <p:spPr>
+          <a:xfrm>
+            <a:off x="914400" y="2057400"/>
+            <a:ext cx="10058400" cy="365760"/>
+          </a:xfrm>
+          <a:prstGeom prst="rect">
+            <a:avLst/>
+          </a:prstGeom>
+          <a:noFill/>
+        </p:spPr>
+        <p:txBody>
+          <a:bodyPr wrap="square" anchor="t" lIns="0" rIns="0" tIns="0" bIns="0">
+            <a:spAutoFit/>
+          </a:bodyPr>
+          <a:lstStyle/>
+          <a:p>
+            <a:pPr algn="l"/>
+            <a:r>
+              <a:rPr sz="1400" b="1" i="0">
+                <a:solidFill>
+                  <a:srgbClr val="0E7490"/>
+                </a:solidFill>
+                <a:latin typeface="Calibri"/>
+              </a:rPr>
+              <a:t>SUPPLIER QUALITY  ·  PELVIC BLOCKS</a:t>
+            </a:r>
+          </a:p>
+        </p:txBody>
+      </p:sp>
+      <p:sp>
+        <p:nvSpPr>
+          <p:cNvPr id="6" name="TextBox 5"/>
+          <p:cNvSpPr txBox="1"/>
+          <p:nvPr/>
+        </p:nvSpPr>
+        <p:spPr>
+          <a:xfrm>
+            <a:off x="877824" y="2468880"/>
+            <a:ext cx="10424160" cy="914400"/>
+          </a:xfrm>
+          <a:prstGeom prst="rect">
+            <a:avLst/>
+          </a:prstGeom>
+          <a:noFill/>
+        </p:spPr>
+        <p:txBody>
+          <a:bodyPr wrap="square" anchor="t" lIns="0" rIns="0" tIns="0" bIns="0">
+            <a:spAutoFit/>
+          </a:bodyPr>
+          <a:lstStyle/>
+          <a:p>
+            <a:pPr algn="l"/>
+            <a:r>
+              <a:rPr sz="4600" b="1" i="0">
+                <a:solidFill>
+                  <a:srgbClr val="1F2937"/>
+                </a:solidFill>
+                <a:latin typeface="Calibri"/>
+              </a:rPr>
+              <a:t>Parks Family Meats</a:t>
+            </a:r>
+          </a:p>
+        </p:txBody>
+      </p:sp>
+      <p:sp>
+        <p:nvSpPr>
+          <p:cNvPr id="7" name="TextBox 6"/>
+          <p:cNvSpPr txBox="1"/>
+          <p:nvPr/>
+        </p:nvSpPr>
+        <p:spPr>
+          <a:xfrm>
+            <a:off x="914400" y="3429000"/>
+            <a:ext cx="10058400" cy="548640"/>
+          </a:xfrm>
+          <a:prstGeom prst="rect">
+            <a:avLst/>
+          </a:prstGeom>
+          <a:noFill/>
+        </p:spPr>
+        <p:txBody>
+          <a:bodyPr wrap="square" anchor="t" lIns="0" rIns="0" tIns="0" bIns="0">
+            <a:spAutoFit/>
+          </a:bodyPr>
+          <a:lstStyle/>
+          <a:p>
+            <a:pPr algn="l"/>
+            <a:r>
+              <a:rPr sz="3000" b="1" i="0">
+                <a:solidFill>
+                  <a:srgbClr val="0E7490"/>
+                </a:solidFill>
+                <a:latin typeface="Calibri"/>
+              </a:rPr>
+              <a:t>Supplier Calls</a:t>
+            </a:r>
+          </a:p>
+        </p:txBody>
+      </p:sp>
+      <p:sp>
+        <p:nvSpPr>
+          <p:cNvPr id="8" name="Rectangle 7"/>
+          <p:cNvSpPr/>
+          <p:nvPr/>
+        </p:nvSpPr>
+        <p:spPr>
+          <a:xfrm>
+            <a:off x="932688" y="4160520"/>
+            <a:ext cx="2194560" cy="45720"/>
+          </a:xfrm>
+          <a:prstGeom prst="rect">
+            <a:avLst/>
+          </a:prstGeom>
+          <a:solidFill>
+            <a:srgbClr val="E5E7EB"/>
+          </a:solidFill>
+          <a:ln>
+            <a:noFill/>
+          </a:ln>
+          <a:effectLst/>
+        </p:spPr>
+        <p:style>
+          <a:lnRef idx="1">
+            <a:schemeClr val="accent1"/>
+          </a:lnRef>
+          <a:fillRef idx="3">
+            <a:schemeClr val="accent1"/>
+          </a:fillRef>
+          <a:effectRef idx="2">
+            <a:schemeClr val="accent1"/>
+          </a:effectRef>
+          <a:fontRef idx="minor">
+            <a:schemeClr val="lt1"/>
+          </a:fontRef>
+        </p:style>
+        <p:txBody>
+          <a:bodyPr rtlCol="0" anchor="ctr"/>
+          <a:lstStyle/>
+          <a:p>
+            <a:pPr algn="ctr"/>
+          </a:p>
+        </p:txBody>
+      </p:sp>
+      <p:sp>
+        <p:nvSpPr>
+          <p:cNvPr id="9" name="TextBox 8"/>
+          <p:cNvSpPr txBox="1"/>
+          <p:nvPr/>
+        </p:nvSpPr>
+        <p:spPr>
+          <a:xfrm>
+            <a:off x="914400" y="4315968"/>
+            <a:ext cx="10058400" cy="365760"/>
+          </a:xfrm>
+          <a:prstGeom prst="rect">
+            <a:avLst/>
+          </a:prstGeom>
+          <a:noFill/>
+        </p:spPr>
+        <p:txBody>
+          <a:bodyPr wrap="square" anchor="t" lIns="0" rIns="0" tIns="0" bIns="0">
+            <a:spAutoFit/>
+          </a:bodyPr>
+          <a:lstStyle/>
+          <a:p>
+            <a:pPr algn="l"/>
+            <a:r>
+              <a:rPr sz="1500" b="0" i="0">
+                <a:solidFill>
+                  <a:srgbClr val="6B7280"/>
+                </a:solidFill>
+                <a:latin typeface="Calibri"/>
+              </a:rPr>
+              <a:t>Quality Review — Pelvic Blocks  ·  June–July 2026</a:t>
+            </a:r>
+          </a:p>
+        </p:txBody>
+      </p:sp>
+      <p:sp>
+        <p:nvSpPr>
+          <p:cNvPr id="10" name="TextBox 9"/>
+          <p:cNvSpPr txBox="1"/>
+          <p:nvPr/>
+        </p:nvSpPr>
+        <p:spPr>
+          <a:xfrm>
+            <a:off x="914400" y="5943600"/>
+            <a:ext cx="10058400" cy="320040"/>
+          </a:xfrm>
+          <a:prstGeom prst="rect">
+            <a:avLst/>
+          </a:prstGeom>
+          <a:noFill/>
+        </p:spPr>
+        <p:txBody>
+          <a:bodyPr wrap="square" anchor="t" lIns="0" rIns="0" tIns="0" bIns="0">
+            <a:spAutoFit/>
+          </a:bodyPr>
+          <a:lstStyle/>
+          <a:p>
+            <a:pPr algn="l"/>
+            <a:r>
+              <a:rPr sz="1200" b="0" i="1">
+                <a:solidFill>
+                  <a:srgbClr val="6B7280"/>
+                </a:solidFill>
+                <a:latin typeface="Calibri"/>
+              </a:rPr>
+              <a:t>ATM Incoming Quality  ·  prepared for the Parks + ATM receiving team</a:t>
+            </a:r>
+          </a:p>
+        </p:txBody>
+      </p:sp>
+      <p:sp>
+        <p:nvSpPr>
+          <p:cNvPr id="11" name="TextBox 10"/>
+          <p:cNvSpPr txBox="1"/>
+          <p:nvPr/>
+        </p:nvSpPr>
+        <p:spPr>
+          <a:xfrm>
+            <a:off x="0" y="6473952"/>
+            <a:ext cx="12191695" cy="365760"/>
+          </a:xfrm>
+          <a:prstGeom prst="rect">
+            <a:avLst/>
+          </a:prstGeom>
+          <a:noFill/>
+        </p:spPr>
+        <p:txBody>
+          <a:bodyPr wrap="square" anchor="ctr" lIns="0" rIns="0" tIns="0" bIns="0">
+            <a:spAutoFit/>
+          </a:bodyPr>
+          <a:lstStyle/>
+          <a:p>
+            <a:pPr algn="ctr"/>
+            <a:r>
+              <a:rPr sz="1100" b="0" i="0">
+                <a:solidFill>
+                  <a:srgbClr val="FFFFFF"/>
+                </a:solidFill>
+                <a:latin typeface="Calibri"/>
+              </a:rPr>
+              <a:t>Parks Family Meats — Supplier Calls</a:t>
+            </a:r>
+          </a:p>
+        </p:txBody>
+      </p:sp>
+    </p:spTree>
+  </p:cSld>
+  <p:clrMapOvr>
+    <a:masterClrMapping/>
+  </p:clrMapOvr>
+</p:sld>
+</file>
+
+<file path=ppt/slides/slide5.xml><?xml version="1.0" encoding="utf-8"?>
+<p:sld xmlns:a="http://schemas.openxmlformats.org/drawingml/2006/main" xmlns:p="http://schemas.openxmlformats.org/presentationml/2006/main" xmlns:r="http://schemas.openxmlformats.org/officeDocument/2006/relationships">
+  <p:cSld>
+    <p:spTree>
+      <p:nvGrpSpPr>
+        <p:cNvPr id="1" name=""/>
+        <p:cNvGrpSpPr/>
+        <p:nvPr/>
+      </p:nvGrpSpPr>
+      <p:grpSpPr/>
+      <p:sp>
+        <p:nvSpPr>
+          <p:cNvPr id="2" name="Rectangle 1"/>
+          <p:cNvSpPr/>
+          <p:nvPr/>
+        </p:nvSpPr>
+        <p:spPr>
+          <a:xfrm>
+            <a:off x="0" y="0"/>
+            <a:ext cx="12191695" cy="6858000"/>
+          </a:xfrm>
+          <a:prstGeom prst="rect">
+            <a:avLst/>
+          </a:prstGeom>
+          <a:solidFill>
+            <a:srgbClr val="FFFFFF"/>
+          </a:solidFill>
+          <a:ln>
+            <a:noFill/>
+          </a:ln>
+          <a:effectLst/>
+        </p:spPr>
+        <p:style>
+          <a:lnRef idx="1">
+            <a:schemeClr val="accent1"/>
+          </a:lnRef>
+          <a:fillRef idx="3">
+            <a:schemeClr val="accent1"/>
+          </a:fillRef>
+          <a:effectRef idx="2">
+            <a:schemeClr val="accent1"/>
+          </a:effectRef>
+          <a:fontRef idx="minor">
+            <a:schemeClr val="lt1"/>
+          </a:fontRef>
+        </p:style>
+        <p:txBody>
+          <a:bodyPr rtlCol="0" anchor="ctr"/>
+          <a:lstStyle/>
+          <a:p>
+            <a:pPr algn="ctr"/>
+          </a:p>
+        </p:txBody>
+      </p:sp>
+      <p:sp>
+        <p:nvSpPr>
+          <p:cNvPr id="3" name="TextBox 2"/>
+          <p:cNvSpPr txBox="1"/>
+          <p:nvPr/>
+        </p:nvSpPr>
+        <p:spPr>
+          <a:xfrm>
+            <a:off x="502920" y="292608"/>
+            <a:ext cx="11155680" cy="548640"/>
+          </a:xfrm>
+          <a:prstGeom prst="rect">
+            <a:avLst/>
+          </a:prstGeom>
+          <a:noFill/>
+        </p:spPr>
+        <p:txBody>
+          <a:bodyPr wrap="square" anchor="t" lIns="0" rIns="0" tIns="0" bIns="0">
+            <a:spAutoFit/>
+          </a:bodyPr>
+          <a:lstStyle/>
+          <a:p>
+            <a:pPr algn="l"/>
+            <a:r>
+              <a:rPr sz="3000" b="1" i="0">
+                <a:solidFill>
+                  <a:srgbClr val="1F2937"/>
+                </a:solidFill>
+                <a:latin typeface="Calibri"/>
+              </a:rPr>
+              <a:t>Follow-up &amp; next steps</a:t>
+            </a:r>
+          </a:p>
+        </p:txBody>
+      </p:sp>
+      <p:sp>
+        <p:nvSpPr>
+          <p:cNvPr id="4" name="Rectangle 3"/>
+          <p:cNvSpPr/>
+          <p:nvPr/>
+        </p:nvSpPr>
+        <p:spPr>
+          <a:xfrm>
+            <a:off x="502920" y="896112"/>
+            <a:ext cx="1371600" cy="50292"/>
+          </a:xfrm>
+          <a:prstGeom prst="rect">
+            <a:avLst/>
+          </a:prstGeom>
+          <a:solidFill>
+            <a:srgbClr val="0E7490"/>
+          </a:solidFill>
+          <a:ln>
+            <a:noFill/>
+          </a:ln>
+          <a:effectLst/>
+        </p:spPr>
+        <p:style>
+          <a:lnRef idx="1">
+            <a:schemeClr val="accent1"/>
+          </a:lnRef>
+          <a:fillRef idx="3">
+            <a:schemeClr val="accent1"/>
+          </a:fillRef>
+          <a:effectRef idx="2">
+            <a:schemeClr val="accent1"/>
+          </a:effectRef>
+          <a:fontRef idx="minor">
+            <a:schemeClr val="lt1"/>
+          </a:fontRef>
+        </p:style>
+        <p:txBody>
+          <a:bodyPr rtlCol="0" anchor="ctr"/>
+          <a:lstStyle/>
+          <a:p>
+            <a:pPr algn="ctr"/>
+          </a:p>
+        </p:txBody>
+      </p:sp>
+      <p:sp>
+        <p:nvSpPr>
+          <p:cNvPr id="5" name="TextBox 4"/>
+          <p:cNvSpPr txBox="1"/>
+          <p:nvPr/>
+        </p:nvSpPr>
+        <p:spPr>
+          <a:xfrm>
+            <a:off x="502920" y="960120"/>
+            <a:ext cx="11155680" cy="274320"/>
+          </a:xfrm>
+          <a:prstGeom prst="rect">
+            <a:avLst/>
+          </a:prstGeom>
+          <a:noFill/>
+        </p:spPr>
+        <p:txBody>
+          <a:bodyPr wrap="square" anchor="t" lIns="0" rIns="0" tIns="0" bIns="0">
+            <a:spAutoFit/>
+          </a:bodyPr>
+          <a:lstStyle/>
+          <a:p>
+            <a:pPr algn="l"/>
+            <a:r>
+              <a:rPr sz="1350" b="0" i="0">
+                <a:solidFill>
+                  <a:srgbClr val="6B7280"/>
+                </a:solidFill>
+                <a:latin typeface="Calibri"/>
+              </a:rPr>
+              <a:t>Open items from today's call</a:t>
+            </a:r>
+          </a:p>
+        </p:txBody>
+      </p:sp>
+      <p:sp>
+        <p:nvSpPr>
+          <p:cNvPr id="6" name="Rounded Rectangle 5"/>
+          <p:cNvSpPr/>
+          <p:nvPr/>
+        </p:nvSpPr>
+        <p:spPr>
+          <a:xfrm>
+            <a:off x="502920" y="1600200"/>
+            <a:ext cx="11183112" cy="914400"/>
+          </a:xfrm>
+          <a:prstGeom prst="roundRect">
+            <a:avLst>
+              <a:gd name="adj" fmla="val 7000"/>
+            </a:avLst>
+          </a:prstGeom>
+          <a:solidFill>
+            <a:srgbClr val="F9FAFB"/>
+          </a:solidFill>
+          <a:ln w="12700">
+            <a:solidFill>
+              <a:srgbClr val="E5E7EB"/>
+            </a:solidFill>
+          </a:ln>
+          <a:effectLst/>
+        </p:spPr>
+        <p:style>
+          <a:lnRef idx="1">
+            <a:schemeClr val="accent1"/>
+          </a:lnRef>
+          <a:fillRef idx="3">
+            <a:schemeClr val="accent1"/>
+          </a:fillRef>
+          <a:effectRef idx="2">
+            <a:schemeClr val="accent1"/>
+          </a:effectRef>
+          <a:fontRef idx="minor">
+            <a:schemeClr val="lt1"/>
+          </a:fontRef>
+        </p:style>
+        <p:txBody>
+          <a:bodyPr rtlCol="0" anchor="ctr"/>
+          <a:lstStyle/>
+          <a:p>
+            <a:pPr algn="ctr"/>
+          </a:p>
+        </p:txBody>
+      </p:sp>
+      <p:sp>
+        <p:nvSpPr>
+          <p:cNvPr id="7" name="Rectangle 6"/>
+          <p:cNvSpPr/>
+          <p:nvPr/>
+        </p:nvSpPr>
+        <p:spPr>
+          <a:xfrm>
+            <a:off x="502920" y="1600200"/>
+            <a:ext cx="109728" cy="914400"/>
+          </a:xfrm>
+          <a:prstGeom prst="rect">
+            <a:avLst/>
+          </a:prstGeom>
+          <a:solidFill>
+            <a:srgbClr val="0E7490"/>
+          </a:solidFill>
+          <a:ln>
+            <a:noFill/>
+          </a:ln>
+          <a:effectLst/>
+        </p:spPr>
+        <p:style>
+          <a:lnRef idx="1">
+            <a:schemeClr val="accent1"/>
+          </a:lnRef>
+          <a:fillRef idx="3">
+            <a:schemeClr val="accent1"/>
+          </a:fillRef>
+          <a:effectRef idx="2">
+            <a:schemeClr val="accent1"/>
+          </a:effectRef>
+          <a:fontRef idx="minor">
+            <a:schemeClr val="lt1"/>
+          </a:fontRef>
+        </p:style>
+        <p:txBody>
+          <a:bodyPr rtlCol="0" anchor="ctr"/>
+          <a:lstStyle/>
+          <a:p>
+            <a:pPr algn="ctr"/>
+          </a:p>
+        </p:txBody>
+      </p:sp>
+      <p:sp>
+        <p:nvSpPr>
+          <p:cNvPr id="8" name="Oval 7"/>
+          <p:cNvSpPr/>
+          <p:nvPr/>
+        </p:nvSpPr>
+        <p:spPr>
+          <a:xfrm>
+            <a:off x="822960" y="1874519"/>
+            <a:ext cx="365760" cy="365760"/>
+          </a:xfrm>
+          <a:prstGeom prst="ellipse">
+            <a:avLst/>
+          </a:prstGeom>
+          <a:solidFill>
+            <a:srgbClr val="0E7490"/>
+          </a:solidFill>
+          <a:ln>
+            <a:noFill/>
+          </a:ln>
+          <a:effectLst/>
+        </p:spPr>
+        <p:style>
+          <a:lnRef idx="1">
+            <a:schemeClr val="accent1"/>
+          </a:lnRef>
+          <a:fillRef idx="3">
+            <a:schemeClr val="accent1"/>
+          </a:fillRef>
+          <a:effectRef idx="2">
+            <a:schemeClr val="accent1"/>
+          </a:effectRef>
+          <a:fontRef idx="minor">
+            <a:schemeClr val="lt1"/>
+          </a:fontRef>
+        </p:style>
+        <p:txBody>
+          <a:bodyPr rtlCol="0" anchor="ctr" tIns="0" bIns="0"/>
+          <a:lstStyle/>
+          <a:p>
+            <a:pPr algn="ctr"/>
+            <a:r>
+              <a:rPr sz="1600" b="1">
+                <a:solidFill>
+                  <a:srgbClr val="FFFFFF"/>
+                </a:solidFill>
+                <a:latin typeface="Calibri"/>
+              </a:rPr>
+              <a:t>1</a:t>
+            </a:r>
+          </a:p>
+        </p:txBody>
+      </p:sp>
+      <p:sp>
+        <p:nvSpPr>
+          <p:cNvPr id="9" name="TextBox 8"/>
+          <p:cNvSpPr txBox="1"/>
+          <p:nvPr/>
+        </p:nvSpPr>
+        <p:spPr>
+          <a:xfrm>
+            <a:off x="1417320" y="1600200"/>
+            <a:ext cx="9601200" cy="914400"/>
+          </a:xfrm>
+          <a:prstGeom prst="rect">
+            <a:avLst/>
+          </a:prstGeom>
+          <a:noFill/>
+        </p:spPr>
+        <p:txBody>
+          <a:bodyPr wrap="square" anchor="ctr" lIns="0" rIns="0" tIns="0" bIns="0">
+            <a:spAutoFit/>
+          </a:bodyPr>
+          <a:lstStyle/>
+          <a:p>
+            <a:pPr algn="l"/>
+            <a:r>
+              <a:rPr sz="1600" b="1" i="0">
+                <a:solidFill>
+                  <a:srgbClr val="1F2937"/>
+                </a:solidFill>
+                <a:latin typeface="Calibri"/>
+              </a:rPr>
+              <a:t>Did Parks receive the labels and work instructions for the 666541s?</a:t>
+            </a:r>
+          </a:p>
+        </p:txBody>
+      </p:sp>
+      <p:sp>
+        <p:nvSpPr>
+          <p:cNvPr id="10" name="Rounded Rectangle 9"/>
+          <p:cNvSpPr/>
+          <p:nvPr/>
+        </p:nvSpPr>
+        <p:spPr>
+          <a:xfrm>
+            <a:off x="502920" y="2697480"/>
+            <a:ext cx="11183112" cy="914400"/>
+          </a:xfrm>
+          <a:prstGeom prst="roundRect">
+            <a:avLst>
+              <a:gd name="adj" fmla="val 7000"/>
+            </a:avLst>
+          </a:prstGeom>
+          <a:solidFill>
+            <a:srgbClr val="F9FAFB"/>
+          </a:solidFill>
+          <a:ln w="12700">
+            <a:solidFill>
+              <a:srgbClr val="E5E7EB"/>
+            </a:solidFill>
+          </a:ln>
+          <a:effectLst/>
+        </p:spPr>
+        <p:style>
+          <a:lnRef idx="1">
+            <a:schemeClr val="accent1"/>
+          </a:lnRef>
+          <a:fillRef idx="3">
+            <a:schemeClr val="accent1"/>
+          </a:fillRef>
+          <a:effectRef idx="2">
+            <a:schemeClr val="accent1"/>
+          </a:effectRef>
+          <a:fontRef idx="minor">
+            <a:schemeClr val="lt1"/>
+          </a:fontRef>
+        </p:style>
+        <p:txBody>
+          <a:bodyPr rtlCol="0" anchor="ctr"/>
+          <a:lstStyle/>
+          <a:p>
+            <a:pPr algn="ctr"/>
+          </a:p>
+        </p:txBody>
+      </p:sp>
+      <p:sp>
+        <p:nvSpPr>
+          <p:cNvPr id="11" name="Rectangle 10"/>
+          <p:cNvSpPr/>
+          <p:nvPr/>
+        </p:nvSpPr>
+        <p:spPr>
+          <a:xfrm>
+            <a:off x="502920" y="2697480"/>
+            <a:ext cx="109728" cy="914400"/>
+          </a:xfrm>
+          <a:prstGeom prst="rect">
+            <a:avLst/>
+          </a:prstGeom>
+          <a:solidFill>
+            <a:srgbClr val="0E7490"/>
+          </a:solidFill>
+          <a:ln>
+            <a:noFill/>
+          </a:ln>
+          <a:effectLst/>
+        </p:spPr>
+        <p:style>
+          <a:lnRef idx="1">
+            <a:schemeClr val="accent1"/>
+          </a:lnRef>
+          <a:fillRef idx="3">
+            <a:schemeClr val="accent1"/>
+          </a:fillRef>
+          <a:effectRef idx="2">
+            <a:schemeClr val="accent1"/>
+          </a:effectRef>
+          <a:fontRef idx="minor">
+            <a:schemeClr val="lt1"/>
+          </a:fontRef>
+        </p:style>
+        <p:txBody>
+          <a:bodyPr rtlCol="0" anchor="ctr"/>
+          <a:lstStyle/>
+          <a:p>
+            <a:pPr algn="ctr"/>
+          </a:p>
+        </p:txBody>
+      </p:sp>
+      <p:sp>
+        <p:nvSpPr>
+          <p:cNvPr id="12" name="Oval 11"/>
+          <p:cNvSpPr/>
+          <p:nvPr/>
+        </p:nvSpPr>
+        <p:spPr>
+          <a:xfrm>
+            <a:off x="822960" y="2971800"/>
+            <a:ext cx="365760" cy="365760"/>
+          </a:xfrm>
+          <a:prstGeom prst="ellipse">
+            <a:avLst/>
+          </a:prstGeom>
+          <a:solidFill>
+            <a:srgbClr val="0E7490"/>
+          </a:solidFill>
+          <a:ln>
+            <a:noFill/>
+          </a:ln>
+          <a:effectLst/>
+        </p:spPr>
+        <p:style>
+          <a:lnRef idx="1">
+            <a:schemeClr val="accent1"/>
+          </a:lnRef>
+          <a:fillRef idx="3">
+            <a:schemeClr val="accent1"/>
+          </a:fillRef>
+          <a:effectRef idx="2">
+            <a:schemeClr val="accent1"/>
+          </a:effectRef>
+          <a:fontRef idx="minor">
+            <a:schemeClr val="lt1"/>
+          </a:fontRef>
+        </p:style>
+        <p:txBody>
+          <a:bodyPr rtlCol="0" anchor="ctr" tIns="0" bIns="0"/>
+          <a:lstStyle/>
+          <a:p>
+            <a:pPr algn="ctr"/>
+            <a:r>
+              <a:rPr sz="1600" b="1">
+                <a:solidFill>
+                  <a:srgbClr val="FFFFFF"/>
+                </a:solidFill>
+                <a:latin typeface="Calibri"/>
+              </a:rPr>
+              <a:t>2</a:t>
+            </a:r>
+          </a:p>
+        </p:txBody>
+      </p:sp>
+      <p:sp>
+        <p:nvSpPr>
+          <p:cNvPr id="13" name="TextBox 12"/>
+          <p:cNvSpPr txBox="1"/>
+          <p:nvPr/>
+        </p:nvSpPr>
+        <p:spPr>
+          <a:xfrm>
+            <a:off x="1417320" y="2697480"/>
+            <a:ext cx="9601200" cy="914400"/>
+          </a:xfrm>
+          <a:prstGeom prst="rect">
+            <a:avLst/>
+          </a:prstGeom>
+          <a:noFill/>
+        </p:spPr>
+        <p:txBody>
+          <a:bodyPr wrap="square" anchor="ctr" lIns="0" rIns="0" tIns="0" bIns="0">
+            <a:spAutoFit/>
+          </a:bodyPr>
+          <a:lstStyle/>
+          <a:p>
+            <a:pPr algn="l"/>
+            <a:r>
+              <a:rPr sz="1600" b="1" i="0">
+                <a:solidFill>
+                  <a:srgbClr val="1F2937"/>
+                </a:solidFill>
+                <a:latin typeface="Calibri"/>
+              </a:rPr>
+              <a:t>Are we missing anything else?</a:t>
+            </a:r>
+          </a:p>
+        </p:txBody>
+      </p:sp>
+      <p:sp>
+        <p:nvSpPr>
+          <p:cNvPr id="14" name="Rounded Rectangle 13"/>
+          <p:cNvSpPr/>
+          <p:nvPr/>
+        </p:nvSpPr>
+        <p:spPr>
+          <a:xfrm>
+            <a:off x="502920" y="3931920"/>
+            <a:ext cx="11183112" cy="868680"/>
+          </a:xfrm>
+          <a:prstGeom prst="roundRect">
+            <a:avLst>
+              <a:gd name="adj" fmla="val 7000"/>
+            </a:avLst>
+          </a:prstGeom>
+          <a:solidFill>
+            <a:srgbClr val="CFF0F5"/>
+          </a:solidFill>
+          <a:ln>
+            <a:noFill/>
+          </a:ln>
+          <a:effectLst/>
+        </p:spPr>
+        <p:style>
+          <a:lnRef idx="1">
+            <a:schemeClr val="accent1"/>
+          </a:lnRef>
+          <a:fillRef idx="3">
+            <a:schemeClr val="accent1"/>
+          </a:fillRef>
+          <a:effectRef idx="2">
+            <a:schemeClr val="accent1"/>
+          </a:effectRef>
+          <a:fontRef idx="minor">
+            <a:schemeClr val="lt1"/>
+          </a:fontRef>
+        </p:style>
+        <p:txBody>
+          <a:bodyPr rtlCol="0" anchor="ctr"/>
+          <a:lstStyle/>
+          <a:p>
+            <a:pPr algn="ctr"/>
+          </a:p>
+        </p:txBody>
+      </p:sp>
+      <p:sp>
+        <p:nvSpPr>
+          <p:cNvPr id="15" name="TextBox 14"/>
+          <p:cNvSpPr txBox="1"/>
+          <p:nvPr/>
+        </p:nvSpPr>
+        <p:spPr>
+          <a:xfrm>
+            <a:off x="777240" y="4041648"/>
+            <a:ext cx="1280160" cy="640080"/>
+          </a:xfrm>
+          <a:prstGeom prst="rect">
+            <a:avLst/>
+          </a:prstGeom>
+          <a:noFill/>
+        </p:spPr>
+        <p:txBody>
+          <a:bodyPr wrap="square" anchor="ctr" lIns="0" rIns="0" tIns="0" bIns="0">
+            <a:spAutoFit/>
+          </a:bodyPr>
+          <a:lstStyle/>
+          <a:p>
+            <a:pPr algn="l"/>
+            <a:r>
+              <a:rPr sz="1100" b="1" i="0">
+                <a:solidFill>
+                  <a:srgbClr val="0E7490"/>
+                </a:solidFill>
+                <a:latin typeface="Calibri"/>
+              </a:rPr>
+              <a:t>NOTE</a:t>
+            </a:r>
+          </a:p>
+        </p:txBody>
+      </p:sp>
+      <p:sp>
+        <p:nvSpPr>
+          <p:cNvPr id="16" name="TextBox 15"/>
+          <p:cNvSpPr txBox="1"/>
+          <p:nvPr/>
+        </p:nvSpPr>
+        <p:spPr>
+          <a:xfrm>
+            <a:off x="1874519" y="3931920"/>
+            <a:ext cx="9692640" cy="868680"/>
+          </a:xfrm>
+          <a:prstGeom prst="rect">
+            <a:avLst/>
+          </a:prstGeom>
+          <a:noFill/>
+        </p:spPr>
+        <p:txBody>
+          <a:bodyPr wrap="square" anchor="ctr" lIns="0" rIns="0" tIns="0" bIns="0">
+            <a:spAutoFit/>
+          </a:bodyPr>
+          <a:lstStyle/>
+          <a:p>
+            <a:pPr algn="l"/>
+            <a:r>
+              <a:rPr sz="1600" b="1" i="0">
+                <a:solidFill>
+                  <a:srgbClr val="374151"/>
+                </a:solidFill>
+                <a:latin typeface="Calibri"/>
+              </a:rPr>
+              <a:t>Leaf fat — quality inspections will be performed today.</a:t>
+            </a:r>
+          </a:p>
+        </p:txBody>
+      </p:sp>
+      <p:sp>
+        <p:nvSpPr>
+          <p:cNvPr id="17" name="TextBox 16"/>
+          <p:cNvSpPr txBox="1"/>
+          <p:nvPr/>
+        </p:nvSpPr>
+        <p:spPr>
+          <a:xfrm>
+            <a:off x="502920" y="5257800"/>
+            <a:ext cx="11183112" cy="822960"/>
+          </a:xfrm>
+          <a:prstGeom prst="rect">
+            <a:avLst/>
+          </a:prstGeom>
+          <a:noFill/>
+        </p:spPr>
+        <p:txBody>
+          <a:bodyPr wrap="square" anchor="ctr" lIns="0" rIns="0" tIns="0" bIns="0">
+            <a:spAutoFit/>
+          </a:bodyPr>
+          <a:lstStyle/>
+          <a:p>
+            <a:pPr algn="ctr"/>
+            <a:r>
+              <a:rPr sz="2600" b="1" i="0">
+                <a:solidFill>
+                  <a:srgbClr val="1F2937"/>
+                </a:solidFill>
+                <a:latin typeface="Calibri"/>
+              </a:rPr>
+              <a:t>Thank you for working with us.</a:t>
+            </a:r>
+          </a:p>
+        </p:txBody>
+      </p:sp>
+    </p:spTree>
+  </p:cSld>
+  <p:clrMapOvr>
+    <a:masterClrMapping/>
+  </p:clrMapOvr>
+</p:sld>
+</file>
+
 <file path=ppt/theme/theme1.xml><?xml version="1.0" encoding="utf-8"?>
 <a:theme xmlns:a="http://schemas.openxmlformats.org/drawingml/2006/main" name="Office Theme">
   <a:themeElements>

</xml_diff>